<commit_message>
Presentacion: precisa alcance, costo de M1 y enlace al repositorio
- "clima" -> "meteorologia del dia" (portada, diapositivas y leyenda ROC).
- Objetivo: clasificacion retrospectiva; 25 ug/m3 como referencia fija, no evaluacion normativa.
- Decisiones fijadas antes del ajuste definitivo, con el ensayo preliminar 2024-2025 declarado.
- Tarjeta 73 %: falsas alarmas 30 % (M1) vs 27 % (M0), de prueba_metricas_m0_m1.csv.
- Lluvias: "sin mejora concluyente" (IC de dAUC incluye 0).
- Diapositiva 3: captura de la app mas grande y enlace a GitHub.

Co-Authored-By: Claude Opus 5.5 <noreply@anthropic.com>
</commit_message>
<xml_diff>
--- a/docs/presentacion/Presentacion_Etapa3_SIMA.pptx
+++ b/docs/presentacion/Presentacion_Etapa3_SIMA.pptx
@@ -1315,8 +1315,8 @@
         </p:nvSpPr>
         <p:spPr>
           <a:xfrm>
-            <a:off x="548640" y="1005840"/>
-            <a:ext cx="6766560" cy="2011680"/>
+            <a:off x="548640" y="960120"/>
+            <a:ext cx="6766560" cy="2240280"/>
           </a:xfrm>
           <a:prstGeom prst="rect">
             <a:avLst/>
@@ -1340,7 +1340,7 @@
                 <a:ea typeface="Calibri" pitchFamily="34" charset="-122"/>
                 <a:cs typeface="Calibri" pitchFamily="34" charset="-120"/>
               </a:rPr>
-              <a:t>¿Cuánto ayuda el clima a identificar los días de PM2.5 alto en Monterrey?</a:t>
+              <a:t>¿Cuánto ayuda la meteorología del día a identificar los días de PM2.5 alto en Monterrey?</a:t>
             </a:r>
             <a:endParaRPr lang="en-US" sz="4000" dirty="0"/>
           </a:p>
@@ -1769,8 +1769,8 @@
         </p:nvSpPr>
         <p:spPr>
           <a:xfrm>
-            <a:off x="457200" y="1097280"/>
-            <a:ext cx="5669280" cy="3246120"/>
+            <a:off x="457200" y="1051560"/>
+            <a:ext cx="6263640" cy="3291840"/>
           </a:xfrm>
           <a:prstGeom prst="rect">
             <a:avLst/>
@@ -1814,7 +1814,7 @@
                 <a:ea typeface="Calibri" pitchFamily="34" charset="-122"/>
                 <a:cs typeface="Calibri" pitchFamily="34" charset="-120"/>
               </a:rPr>
-              <a:t>medir cuánto mejora la meteorología del día la identificación de días-estación con PM2.5 &gt; 25 µg/m³ (24 h, NOM-025-SSA1-2021), frente a solo conocer estación y temporada.</a:t>
+              <a:t>medir cuánto mejora la meteorología del día la clasificación retrospectiva de días-estación con PM2.5 &gt; 25 µg/m³ (24 h), frente a solo conocer estación y temporada. Los 25 µg/m³ (NOM-025-SSA1-2021) son una referencia fija, no una evaluación normativa.</a:t>
             </a:r>
             <a:endParaRPr lang="en-US" sz="2000" dirty="0"/>
           </a:p>
@@ -1910,8 +1910,8 @@
         </p:blipFill>
         <p:spPr>
           <a:xfrm>
-            <a:off x="6355080" y="1051560"/>
-            <a:ext cx="5376672" cy="2775057"/>
+            <a:off x="6903720" y="1143000"/>
+            <a:ext cx="4828032" cy="2491887"/>
           </a:xfrm>
           <a:prstGeom prst="rect">
             <a:avLst/>
@@ -1926,8 +1926,8 @@
         </p:nvSpPr>
         <p:spPr>
           <a:xfrm>
-            <a:off x="6355080" y="3858768"/>
-            <a:ext cx="5376672" cy="365760"/>
+            <a:off x="6903720" y="3749040"/>
+            <a:ext cx="4828032" cy="365760"/>
           </a:xfrm>
           <a:prstGeom prst="rect">
             <a:avLst/>
@@ -2398,11 +2398,11 @@
         <p:spPr>
           <a:xfrm>
             <a:off x="457200" y="1097280"/>
-            <a:ext cx="3429000" cy="1874520"/>
+            <a:ext cx="3429000" cy="2194560"/>
           </a:xfrm>
           <a:prstGeom prst="roundRect">
             <a:avLst>
-              <a:gd name="adj" fmla="val 5854"/>
+              <a:gd name="adj" fmla="val 5000"/>
             </a:avLst>
           </a:prstGeom>
           <a:solidFill>
@@ -2492,7 +2492,7 @@
         <p:spPr>
           <a:xfrm>
             <a:off x="640080" y="1993392"/>
-            <a:ext cx="3063240" cy="868680"/>
+            <a:ext cx="3063240" cy="1188720"/>
           </a:xfrm>
           <a:prstGeom prst="rect">
             <a:avLst/>
@@ -2531,11 +2531,11 @@
         <p:spPr>
           <a:xfrm>
             <a:off x="4023360" y="1097280"/>
-            <a:ext cx="3429000" cy="1874520"/>
+            <a:ext cx="3429000" cy="2194560"/>
           </a:xfrm>
           <a:prstGeom prst="roundRect">
             <a:avLst>
-              <a:gd name="adj" fmla="val 5854"/>
+              <a:gd name="adj" fmla="val 5000"/>
             </a:avLst>
           </a:prstGeom>
           <a:solidFill>
@@ -2625,7 +2625,7 @@
         <p:spPr>
           <a:xfrm>
             <a:off x="4206240" y="1993392"/>
-            <a:ext cx="3063240" cy="868680"/>
+            <a:ext cx="3063240" cy="1188720"/>
           </a:xfrm>
           <a:prstGeom prst="rect">
             <a:avLst/>
@@ -2649,7 +2649,7 @@
                 <a:ea typeface="Calibri" pitchFamily="34" charset="-122"/>
                 <a:cs typeface="Calibri" pitchFamily="34" charset="-120"/>
               </a:rPr>
-              <a:t>de las superaciones detectadas (M1 vs M0)</a:t>
+              <a:t>de las superaciones detectadas (M1 vs M0); falsas alarmas: 30 % vs 27 %</a:t>
             </a:r>
             <a:endParaRPr lang="en-US" sz="2000" dirty="0"/>
           </a:p>
@@ -2664,11 +2664,11 @@
         <p:spPr>
           <a:xfrm>
             <a:off x="7589520" y="1097280"/>
-            <a:ext cx="2057400" cy="1874520"/>
+            <a:ext cx="2057400" cy="2194560"/>
           </a:xfrm>
           <a:prstGeom prst="roundRect">
             <a:avLst>
-              <a:gd name="adj" fmla="val 5854"/>
+              <a:gd name="adj" fmla="val 5333"/>
             </a:avLst>
           </a:prstGeom>
           <a:solidFill>
@@ -2730,7 +2730,7 @@
         <p:spPr>
           <a:xfrm>
             <a:off x="7772400" y="1993392"/>
-            <a:ext cx="1691640" cy="868680"/>
+            <a:ext cx="1691640" cy="1188720"/>
           </a:xfrm>
           <a:prstGeom prst="rect">
             <a:avLst/>
@@ -2769,11 +2769,11 @@
         <p:spPr>
           <a:xfrm>
             <a:off x="9784080" y="1097280"/>
-            <a:ext cx="1947672" cy="1874520"/>
+            <a:ext cx="1947672" cy="2194560"/>
           </a:xfrm>
           <a:prstGeom prst="roundRect">
             <a:avLst>
-              <a:gd name="adj" fmla="val 5854"/>
+              <a:gd name="adj" fmla="val 5634"/>
             </a:avLst>
           </a:prstGeom>
           <a:solidFill>
@@ -2835,7 +2835,7 @@
         <p:spPr>
           <a:xfrm>
             <a:off x="9966960" y="1993392"/>
-            <a:ext cx="1581912" cy="868680"/>
+            <a:ext cx="1581912" cy="1188720"/>
           </a:xfrm>
           <a:prstGeom prst="rect">
             <a:avLst/>
@@ -2859,7 +2859,7 @@
                 <a:ea typeface="Calibri" pitchFamily="34" charset="-122"/>
                 <a:cs typeface="Calibri" pitchFamily="34" charset="-120"/>
               </a:rPr>
-              <a:t>en mar–may; casi nada en lluvias</a:t>
+              <a:t>en mar–may; sin mejora concluyente en lluvias</a:t>
             </a:r>
             <a:endParaRPr lang="en-US" sz="2000" dirty="0"/>
           </a:p>
@@ -2873,7 +2873,7 @@
         </p:nvSpPr>
         <p:spPr>
           <a:xfrm>
-            <a:off x="457200" y="3291840"/>
+            <a:off x="457200" y="3474720"/>
             <a:ext cx="5349240" cy="3108960"/>
           </a:xfrm>
           <a:prstGeom prst="rect">
@@ -2902,7 +2902,7 @@
                 <a:ea typeface="Calibri" pitchFamily="34" charset="-122"/>
                 <a:cs typeface="Calibri" pitchFamily="34" charset="-120"/>
               </a:rPr>
-              <a:t>PCA (interdependencia): 3 ejes del clima explican el 67 %</a:t>
+              <a:t>PCA (interdependencia): 3 ejes meteorológicos explican el 67 %</a:t>
             </a:r>
             <a:endParaRPr lang="en-US" sz="2000" dirty="0"/>
           </a:p>
@@ -2923,7 +2923,7 @@
                 <a:ea typeface="Calibri" pitchFamily="34" charset="-122"/>
                 <a:cs typeface="Calibri" pitchFamily="34" charset="-120"/>
               </a:rPr>
-              <a:t>LDA (dependencia): M0 estación + temporada frente a M1 + clima</a:t>
+              <a:t>LDA (dependencia): M0 estación + temporada frente a M1 + meteorología</a:t>
             </a:r>
             <a:endParaRPr lang="en-US" sz="2000" dirty="0"/>
           </a:p>
@@ -2944,7 +2944,7 @@
                 <a:ea typeface="Calibri" pitchFamily="34" charset="-122"/>
                 <a:cs typeface="Calibri" pitchFamily="34" charset="-120"/>
               </a:rPr>
-              <a:t>Entrenamiento 2021–2023, prueba 2024–2025; decisiones fijadas antes</a:t>
+              <a:t>Entrenamiento 2021–2023, prueba 2024–2025; decisiones fijadas antes del ajuste definitivo (ensayo preliminar con 2024–2025, declarado)</a:t>
             </a:r>
             <a:endParaRPr lang="en-US" sz="2000" dirty="0"/>
           </a:p>
@@ -2987,8 +2987,8 @@
         </p:blipFill>
         <p:spPr>
           <a:xfrm>
-            <a:off x="6035040" y="3200400"/>
-            <a:ext cx="5696712" cy="3200400"/>
+            <a:off x="6172200" y="3474720"/>
+            <a:ext cx="5559552" cy="3127248"/>
           </a:xfrm>
           <a:prstGeom prst="rect">
             <a:avLst/>
@@ -3070,7 +3070,7 @@
         <p:spPr>
           <a:xfrm>
             <a:off x="457200" y="1143000"/>
-            <a:ext cx="3977640" cy="3063240"/>
+            <a:ext cx="3520440" cy="3108960"/>
           </a:xfrm>
           <a:prstGeom prst="rect">
             <a:avLst/>
@@ -3174,8 +3174,8 @@
         </p:nvSpPr>
         <p:spPr>
           <a:xfrm>
-            <a:off x="457200" y="4343400"/>
-            <a:ext cx="3977640" cy="2103120"/>
+            <a:off x="457200" y="4297680"/>
+            <a:ext cx="3520440" cy="1828800"/>
           </a:xfrm>
           <a:prstGeom prst="rect">
             <a:avLst/>
@@ -3279,12 +3279,12 @@
         </p:nvSpPr>
         <p:spPr>
           <a:xfrm>
-            <a:off x="4617720" y="1143000"/>
-            <a:ext cx="3703320" cy="5303520"/>
+            <a:off x="4114800" y="1143000"/>
+            <a:ext cx="4526280" cy="4983480"/>
           </a:xfrm>
           <a:prstGeom prst="roundRect">
             <a:avLst>
-              <a:gd name="adj" fmla="val 2963"/>
+              <a:gd name="adj" fmla="val 2424"/>
             </a:avLst>
           </a:prstGeom>
           <a:solidFill>
@@ -3306,8 +3306,8 @@
         </p:nvSpPr>
         <p:spPr>
           <a:xfrm>
-            <a:off x="4818888" y="1280160"/>
-            <a:ext cx="3291840" cy="411480"/>
+            <a:off x="4315968" y="1261872"/>
+            <a:ext cx="4114800" cy="411480"/>
           </a:xfrm>
           <a:prstGeom prst="rect">
             <a:avLst/>
@@ -3353,8 +3353,8 @@
         </p:blipFill>
         <p:spPr>
           <a:xfrm>
-            <a:off x="4818888" y="1828800"/>
-            <a:ext cx="3291840" cy="3041660"/>
+            <a:off x="4407408" y="1737360"/>
+            <a:ext cx="3931920" cy="3633094"/>
           </a:xfrm>
           <a:prstGeom prst="rect">
             <a:avLst/>
@@ -3369,8 +3369,8 @@
         </p:nvSpPr>
         <p:spPr>
           <a:xfrm>
-            <a:off x="4818888" y="5029200"/>
-            <a:ext cx="3291840" cy="1280160"/>
+            <a:off x="4315968" y="5440680"/>
+            <a:ext cx="4114800" cy="640080"/>
           </a:xfrm>
           <a:prstGeom prst="rect">
             <a:avLst/>
@@ -3394,7 +3394,7 @@
                 <a:ea typeface="Calibri" pitchFamily="34" charset="-122"/>
                 <a:cs typeface="Calibri" pitchFamily="34" charset="-120"/>
               </a:rPr>
-              <a:t>Estación, temporada y clima → probabilidad de superación</a:t>
+              <a:t>Estación, temporada y meteorología → probabilidad de superación</a:t>
             </a:r>
             <a:endParaRPr lang="en-US" sz="2000" dirty="0"/>
           </a:p>
@@ -3408,12 +3408,12 @@
         </p:nvSpPr>
         <p:spPr>
           <a:xfrm>
-            <a:off x="8503920" y="1143000"/>
-            <a:ext cx="3227832" cy="5303520"/>
+            <a:off x="8778240" y="1143000"/>
+            <a:ext cx="2953512" cy="4983480"/>
           </a:xfrm>
           <a:prstGeom prst="roundRect">
             <a:avLst>
-              <a:gd name="adj" fmla="val 3399"/>
+              <a:gd name="adj" fmla="val 3715"/>
             </a:avLst>
           </a:prstGeom>
           <a:solidFill>
@@ -3435,8 +3435,8 @@
         </p:nvSpPr>
         <p:spPr>
           <a:xfrm>
-            <a:off x="8686800" y="1280160"/>
-            <a:ext cx="2907792" cy="5029200"/>
+            <a:off x="8942832" y="1261872"/>
+            <a:ext cx="2651760" cy="4800600"/>
           </a:xfrm>
           <a:prstGeom prst="rect">
             <a:avLst/>
@@ -3550,6 +3550,66 @@
               <a:t>¿Les serviría una alerta con pronóstico?</a:t>
             </a:r>
             <a:endParaRPr lang="en-US" sz="2200" dirty="0"/>
+          </a:p>
+        </p:txBody>
+      </p:sp>
+      <p:sp>
+        <p:nvSpPr>
+          <p:cNvPr id="11" name="enlace_repositorio"/>
+          <p:cNvSpPr txBox="1"/>
+          <p:nvPr/>
+        </p:nvSpPr>
+        <p:spPr>
+          <a:xfrm>
+            <a:off x="457200" y="6263640"/>
+            <a:ext cx="11274552" cy="365760"/>
+          </a:xfrm>
+          <a:prstGeom prst="rect">
+            <a:avLst/>
+          </a:prstGeom>
+          <a:noFill/>
+          <a:ln/>
+        </p:spPr>
+        <p:txBody>
+          <a:bodyPr wrap="square" lIns="0" tIns="0" rIns="0" bIns="0" rtlCol="0" anchor="ctr"/>
+          <a:lstStyle/>
+          <a:p>
+            <a:pPr indent="0" marL="0">
+              <a:buNone/>
+            </a:pPr>
+            <a:r>
+              <a:rPr lang="en-US" sz="2000" b="1" dirty="0">
+                <a:solidFill>
+                  <a:srgbClr val="1F2933"/>
+                </a:solidFill>
+                <a:latin typeface="Calibri" pitchFamily="34" charset="0"/>
+                <a:ea typeface="Calibri" pitchFamily="34" charset="-122"/>
+                <a:cs typeface="Calibri" pitchFamily="34" charset="-120"/>
+              </a:rPr>
+              <a:t>Código y app: </a:t>
+            </a:r>
+            <a:pPr indent="0" marL="0">
+              <a:buNone/>
+            </a:pPr>
+            <a:r>
+              <a:rPr lang="en-US" sz="2000" u="sng" dirty="0">
+                <a:solidFill>
+                  <a:srgbClr val="0072B2"/>
+                </a:solidFill>
+                <a:latin typeface="Calibri" pitchFamily="34" charset="0"/>
+                <a:ea typeface="Calibri" pitchFamily="34" charset="-122"/>
+                <a:cs typeface="Calibri" pitchFamily="34" charset="-120"/>
+                <a:hlinkClick r:id="rId2" invalidUrl="" action="" tgtFrame="" tooltip="" history="1" highlightClick="0" endSnd="0">
+                  <a:extLst>
+                    <a:ext uri="{A12FA001-AC4F-418D-AE19-62706E023703}">
+                      <ahyp:hlinkClr xmlns:ahyp="http://schemas.microsoft.com/office/drawing/2018/hyperlinkcolor" val="tx"/>
+                    </a:ext>
+                  </a:extLst>
+                </a:hlinkClick>
+              </a:rPr>
+              <a:t>github.com/Leo-issacs/reto-sima-multivariados</a:t>
+            </a:r>
+            <a:endParaRPr lang="en-US" sz="2000" dirty="0"/>
           </a:p>
         </p:txBody>
       </p:sp>

</xml_diff>

<commit_message>
Presentacion: ajustes finales con SIMA (diapositiva 3 con 'Para SIMA', guion y notas)
Co-Authored-By: Claude Sonnet 5.5 <noreply@anthropic.com>
</commit_message>
<xml_diff>
--- a/docs/presentacion/Presentacion_Etapa3_SIMA.pptx
+++ b/docs/presentacion/Presentacion_Etapa3_SIMA.pptx
@@ -505,7 +505,7 @@
           <a:p>
             <a:r>
               <a:rPr lang="en-US" dirty="0"/>
-              <a:t>Buenos días. Somos el equipo 1. Nuestro proyecto se llama «¿Cuánto ayuda el clima a identificar los días de PM2.5 alto en Monterrey?». Trabajamos con los datos horarios de SIMA de 2020 a 2025.</a:t>
+              <a:t>Buenos días. Somos el equipo 1. Nuestro proyecto se llama «¿Cuánto ayuda la meteorología del día a identificar los días de PM2.5 alto en Monterrey?».</a:t>
             </a:r>
             <a:endParaRPr lang="en-US" dirty="0"/>
           </a:p>
@@ -593,13 +593,8 @@
           <a:p>
             <a:r>
               <a:rPr lang="en-US" dirty="0"/>
-              <a:t>El PM2.5 tiene evidencia sólida de efectos en la salud por exposición de pocos días. Nuestra pregunta es concreta: ¿cuánto mejora la meteorología del día la identificación de los días en que una estación supera 25 microgramos por metro cúbico, comparado con solo saber qué estación es y en qué temporada estamos? Usamos 25 porque es el límite de 24 horas de la NOM-025 en su etapa final.
-Trabajamos con 13 estaciones, de 2021 a 2025, con el PM2.5 y ocho variables meteorológicas. La unidad es el estación-día.
-Sobre la limpieza:
-- en los archivos originales faltaba el 12 % de los valores horarios, y en PM2.5 el 26 %;
-- invalidamos menos del 1 % por lecturas inconsistentes, como radiación solar de noche o un viento muy distinto al del resto de la red;
-- imputamos 1 %, solo en huecos de hasta 3 horas.
-Al final nos quedaron 15 390 estación-días. En el mapa se ve que el porcentaje de días con superación va de 9 % en SUR a casi 48 % en Juárez.</a:t>
+              <a:t>El PM2.5 tiene evidencia sólida de efectos en la salud por exposición de pocos días. Nuestra pregunta es concreta: ¿cuánto mejora la meteorología del día la identificación de los días en que una estación supera 25 microgramos por metro cúbico, comparado con solo saber qué estación es y en qué temporada estamos? Usamos 25 porque es el límite de 24 horas de la NOM-025 en su etapa final; lo tomamos como referencia fija, no como evaluación normativa.
+Trabajamos con 13 estaciones, de 2021 a 2025, con el PM2.5 y ocho variables meteorológicas. En los archivos originales faltaba el 12 % de los valores horarios, y en PM2.5 el 26 %. Invalidamos menos del 1 % por lecturas inconsistentes e imputamos el 1 %, solo en huecos de hasta 3 horas. Nos quedaron 15 390 estación-días. En el mapa se ve que la superación va de 9 % en SUR a casi 48 % en Juárez.</a:t>
             </a:r>
             <a:endParaRPr lang="en-US" dirty="0"/>
           </a:p>
@@ -687,12 +682,10 @@
           <a:p>
             <a:r>
               <a:rPr lang="en-US" dirty="0"/>
-              <a:t>Usamos dos técnicas multivariadas:
-- Componentes principales, para entender la estructura del clima. Ocho variables se resumen en tres ejes: un día cálido, soleado y ventilado; un día húmedo y lluvioso; y un día de presión baja y poco viento.
-- Análisis discriminante lineal, para comparar dos modelos: M0, que solo sabe la estación y la temporada, y M1, que además conoce el clima del día.
-Entrenamos con 2021 a 2023 y probamos con 2024 y 2025. Las decisiones del modelo quedaron registradas antes de abrir esos años.
+              <a:t>Usamos dos técnicas multivariadas. Componentes principales, para entender la estructura del clima: ocho variables se resumen en tres ejes que explican el 67 % de la variación. Y análisis discriminante lineal, para comparar dos modelos: M0, que solo sabe la estación y la temporada, y M1, que además conoce el clima del día.
+Entrenamos con 2021 a 2023 y probamos con 2024 y 2025. Las decisiones del modelo quedaron registradas antes de la evaluación final.
 El resultado: el AUC sube de 0.72 a 0.79, una mejora de 0.07 con intervalo de confianza de 0.05 a 0.09. En términos prácticos, el modelo con clima detecta el 73 % de los días con superación, contra el 58 % del modelo sin clima, y el 89 % de los episodios mayores de 40.
-La mejora no es igual en todo el año. Es mayor en marzo a mayo y casi nula en temporada de lluvias. Las variables que más pesan son la presión más baja de lo normal, la temperatura dentro de cada temporada y el viento débil. Son asociaciones, no causas comprobadas.</a:t>
+La mejora es mayor de marzo a mayo y no es concluyente en temporada de lluvias. Lo que más pesa es la presión más baja de lo normal, la temperatura dentro de cada temporada y el viento débil. Son asociaciones, no causas comprobadas.</a:t>
             </a:r>
             <a:endParaRPr lang="en-US" dirty="0"/>
           </a:p>
@@ -781,20 +774,13 @@
             <a:r>
               <a:rPr lang="en-US" dirty="0"/>
               <a:t>Encontramos tres problemas:
-- Lecturas sospechosas: viento de hasta 33 metros por segundo en SO2 y NE2 en 2021, y radiación solar de noche en NO2, SE3 y CE. Agregamos una regla de limpieza para ellas.
-- Cambios de equipos: SIMA nos contó que en 2021 cambió los sensores de viento y en 2025 cinco equipos de PM2.5. Revisamos ambos cambios y no alteran la conclusión.
+- Lecturas imposibles: viento de más de 100 kilómetros por hora y radiación solar de noche en algunas estaciones; agregamos reglas para detectarlas.
+- Cambios de equipos y de ubicación: sensores de viento en 2021, cinco equipos de PM2.5 en 2025 y seis estaciones reubicadas entre 2021 y 2022; los revisamos y no alteran la conclusión.
 - Retención desigual: algunas estaciones conservan pocos días.
 Ya tenemos una interfaz donde se elige estación, temporada y clima, y da la probabilidad de superación.
-Lo que sigue:
-- probar el modelo con meteorología pronosticada, para que sirva como alerta;
-- agregar el PM2.5 del día anterior;
-- ajustar cortes por estación.
-Y tenemos preguntas para ustedes:
-- ¿En qué fechas se cambiaron los sensores, y hubo reubicación de estaciones en 2021?
-- ¿Las horas están en tiempo local y en qué unidad está la lluvia?
-- ¿Qué fuentes cercanas explican que Juárez y Santa Catarina superen tanto?
-- ¿Les serviría una alerta basada en pronóstico?
-Gracias.</a:t>
+¿Qué le sirve esto a SIMA? Tres cosas: la meteorología del día sí ayuda, sobre todo de marzo a mayo, y eso justifica probar una alerta con pronóstico; dos reglas de control de calidad que detectaron sensores con fallas y que pueden incorporar; y una base limpia con todo el código abierto.
+Lo que sigue: en la etapa 4, recalibrar las probabilidades, definir un corte por estación e incorporar lo que nos respondan hoy. Después, probar el modelo con meteorología pronosticada, que es lo que lo convertiría en una alerta real.
+Nos ayudaría mucho saber dos cosas: las fechas y coordenadas exactas de los cambios de sensores y de las seis reubicaciones, y si les serviría una alerta basada en pronóstico. Gracias.</a:t>
             </a:r>
             <a:endParaRPr lang="en-US" dirty="0"/>
           </a:p>
@@ -3055,7 +3041,7 @@
                 <a:ea typeface="Calibri" pitchFamily="34" charset="-122"/>
                 <a:cs typeface="Calibri" pitchFamily="34" charset="-120"/>
               </a:rPr>
-              <a:t>Problemas, qué sigue y preguntas para SIMA</a:t>
+              <a:t>Problemas, qué sigue y valor para SIMA</a:t>
             </a:r>
             <a:endParaRPr lang="en-US" sz="3200" dirty="0"/>
           </a:p>
@@ -3069,8 +3055,8 @@
         </p:nvSpPr>
         <p:spPr>
           <a:xfrm>
-            <a:off x="457200" y="1143000"/>
-            <a:ext cx="3520440" cy="3108960"/>
+            <a:off x="457200" y="1097280"/>
+            <a:ext cx="4663440" cy="2743200"/>
           </a:xfrm>
           <a:prstGeom prst="rect">
             <a:avLst/>
@@ -3118,7 +3104,7 @@
                 <a:ea typeface="Calibri" pitchFamily="34" charset="-122"/>
                 <a:cs typeface="Calibri" pitchFamily="34" charset="-120"/>
               </a:rPr>
-              <a:t>Viento (SO2, NE2 en 2021) y radiación nocturna (NO2, SE3, CE): regla nueva</a:t>
+              <a:t>Lecturas imposibles (viento &gt; 100 km/h, radiación nocturna): reglas nuevas</a:t>
             </a:r>
             <a:endParaRPr lang="en-US" sz="2200" dirty="0"/>
           </a:p>
@@ -3139,7 +3125,7 @@
                 <a:ea typeface="Calibri" pitchFamily="34" charset="-122"/>
                 <a:cs typeface="Calibri" pitchFamily="34" charset="-120"/>
               </a:rPr>
-              <a:t>Cambios de equipos 2021/2025: revisados, no cambian la conclusión</a:t>
+              <a:t>Cambios de equipos (2021, 2025) y 6 estaciones reubicadas (2021–22): revisados, no cambian la conclusión</a:t>
             </a:r>
             <a:endParaRPr lang="en-US" sz="2200" dirty="0"/>
           </a:p>
@@ -3174,8 +3160,8 @@
         </p:nvSpPr>
         <p:spPr>
           <a:xfrm>
-            <a:off x="457200" y="4297680"/>
-            <a:ext cx="3520440" cy="1828800"/>
+            <a:off x="457200" y="4023360"/>
+            <a:ext cx="4663440" cy="2194560"/>
           </a:xfrm>
           <a:prstGeom prst="rect">
             <a:avLst/>
@@ -3202,7 +3188,7 @@
                 <a:ea typeface="Calibri" pitchFamily="34" charset="-122"/>
                 <a:cs typeface="Calibri" pitchFamily="34" charset="-120"/>
               </a:rPr>
-              <a:t>Qué sigue</a:t>
+              <a:t>Qué sigue · etapa 4 (24 oct)</a:t>
             </a:r>
             <a:endParaRPr lang="en-US" sz="2200" dirty="0"/>
           </a:p>
@@ -3223,7 +3209,7 @@
                 <a:ea typeface="Calibri" pitchFamily="34" charset="-122"/>
                 <a:cs typeface="Calibri" pitchFamily="34" charset="-120"/>
               </a:rPr>
-              <a:t>Meteorología pronosticada (alerta real)</a:t>
+              <a:t>Recalibrar probabilidades y cortes por estación</a:t>
             </a:r>
             <a:endParaRPr lang="en-US" sz="2200" dirty="0"/>
           </a:p>
@@ -3244,7 +3230,7 @@
                 <a:ea typeface="Calibri" pitchFamily="34" charset="-122"/>
                 <a:cs typeface="Calibri" pitchFamily="34" charset="-120"/>
               </a:rPr>
-              <a:t>PM2.5 del día anterior</a:t>
+              <a:t>Integrar las respuestas de SIMA</a:t>
             </a:r>
             <a:endParaRPr lang="en-US" sz="2200" dirty="0"/>
           </a:p>
@@ -3265,7 +3251,7 @@
                 <a:ea typeface="Calibri" pitchFamily="34" charset="-122"/>
                 <a:cs typeface="Calibri" pitchFamily="34" charset="-120"/>
               </a:rPr>
-              <a:t>Cortes por estación</a:t>
+              <a:t>Después: probar con meteorología pronosticada</a:t>
             </a:r>
             <a:endParaRPr lang="en-US" sz="2200" dirty="0"/>
           </a:p>
@@ -3279,12 +3265,12 @@
         </p:nvSpPr>
         <p:spPr>
           <a:xfrm>
-            <a:off x="4114800" y="1143000"/>
-            <a:ext cx="4526280" cy="4983480"/>
+            <a:off x="5257800" y="1143000"/>
+            <a:ext cx="2788920" cy="4983480"/>
           </a:xfrm>
           <a:prstGeom prst="roundRect">
             <a:avLst>
-              <a:gd name="adj" fmla="val 2424"/>
+              <a:gd name="adj" fmla="val 3934"/>
             </a:avLst>
           </a:prstGeom>
           <a:solidFill>
@@ -3306,8 +3292,8 @@
         </p:nvSpPr>
         <p:spPr>
           <a:xfrm>
-            <a:off x="4315968" y="1261872"/>
-            <a:ext cx="4114800" cy="411480"/>
+            <a:off x="5422392" y="1261872"/>
+            <a:ext cx="2468880" cy="411480"/>
           </a:xfrm>
           <a:prstGeom prst="rect">
             <a:avLst/>
@@ -3353,8 +3339,8 @@
         </p:blipFill>
         <p:spPr>
           <a:xfrm>
-            <a:off x="4407408" y="1737360"/>
-            <a:ext cx="3931920" cy="3633094"/>
+            <a:off x="5394960" y="1783080"/>
+            <a:ext cx="2514600" cy="2323490"/>
           </a:xfrm>
           <a:prstGeom prst="rect">
             <a:avLst/>
@@ -3369,8 +3355,8 @@
         </p:nvSpPr>
         <p:spPr>
           <a:xfrm>
-            <a:off x="4315968" y="5440680"/>
-            <a:ext cx="4114800" cy="640080"/>
+            <a:off x="5422392" y="4206240"/>
+            <a:ext cx="2468880" cy="1828800"/>
           </a:xfrm>
           <a:prstGeom prst="rect">
             <a:avLst/>
@@ -3402,26 +3388,26 @@
       </p:sp>
       <p:sp>
         <p:nvSpPr>
-          <p:cNvPr id="9" name="tarjeta_preguntas"/>
+          <p:cNvPr id="9" name="tarjeta_para_sima"/>
           <p:cNvSpPr/>
           <p:nvPr/>
         </p:nvSpPr>
         <p:spPr>
           <a:xfrm>
-            <a:off x="8778240" y="1143000"/>
-            <a:ext cx="2953512" cy="4983480"/>
+            <a:off x="8183880" y="1143000"/>
+            <a:ext cx="3547872" cy="4983480"/>
           </a:xfrm>
           <a:prstGeom prst="roundRect">
             <a:avLst>
-              <a:gd name="adj" fmla="val 3715"/>
+              <a:gd name="adj" fmla="val 3093"/>
             </a:avLst>
           </a:prstGeom>
           <a:solidFill>
-            <a:srgbClr val="EEF4F9"/>
+            <a:srgbClr val="F1F3F5"/>
           </a:solidFill>
           <a:ln w="12700">
             <a:solidFill>
-              <a:srgbClr val="EEF4F9"/>
+              <a:srgbClr val="F1F3F5"/>
             </a:solidFill>
             <a:prstDash val="solid"/>
           </a:ln>
@@ -3429,14 +3415,39 @@
       </p:sp>
       <p:sp>
         <p:nvSpPr>
-          <p:cNvPr id="10" name="preguntas"/>
+          <p:cNvPr id="10" name="acento_para_sima"/>
+          <p:cNvSpPr/>
+          <p:nvPr/>
+        </p:nvSpPr>
+        <p:spPr>
+          <a:xfrm>
+            <a:off x="8366760" y="1344168"/>
+            <a:ext cx="73152" cy="457200"/>
+          </a:xfrm>
+          <a:prstGeom prst="rect">
+            <a:avLst/>
+          </a:prstGeom>
+          <a:solidFill>
+            <a:srgbClr val="D55E00"/>
+          </a:solidFill>
+          <a:ln w="12700">
+            <a:solidFill>
+              <a:srgbClr val="D55E00"/>
+            </a:solidFill>
+            <a:prstDash val="solid"/>
+          </a:ln>
+        </p:spPr>
+      </p:sp>
+      <p:sp>
+        <p:nvSpPr>
+          <p:cNvPr id="11" name="titulo_para_sima"/>
           <p:cNvSpPr txBox="1"/>
           <p:nvPr/>
         </p:nvSpPr>
         <p:spPr>
           <a:xfrm>
-            <a:off x="8942832" y="1261872"/>
-            <a:ext cx="2651760" cy="4800600"/>
+            <a:off x="8549640" y="1325880"/>
+            <a:ext cx="3017520" cy="502920"/>
           </a:xfrm>
           <a:prstGeom prst="rect">
             <a:avLst/>
@@ -3445,28 +3456,47 @@
           <a:ln/>
         </p:spPr>
         <p:txBody>
+          <a:bodyPr wrap="square" lIns="0" tIns="0" rIns="0" bIns="0" rtlCol="0" anchor="ctr"/>
+          <a:lstStyle/>
+          <a:p>
+            <a:pPr indent="0" marL="0">
+              <a:buNone/>
+            </a:pPr>
+            <a:r>
+              <a:rPr lang="en-US" sz="3200" b="1" dirty="0">
+                <a:solidFill>
+                  <a:srgbClr val="D55E00"/>
+                </a:solidFill>
+                <a:latin typeface="Calibri" pitchFamily="34" charset="0"/>
+                <a:ea typeface="Calibri" pitchFamily="34" charset="-122"/>
+                <a:cs typeface="Calibri" pitchFamily="34" charset="-120"/>
+              </a:rPr>
+              <a:t>Para SIMA</a:t>
+            </a:r>
+            <a:endParaRPr lang="en-US" sz="3200" dirty="0"/>
+          </a:p>
+        </p:txBody>
+      </p:sp>
+      <p:sp>
+        <p:nvSpPr>
+          <p:cNvPr id="12" name="texto_para_sima"/>
+          <p:cNvSpPr txBox="1"/>
+          <p:nvPr/>
+        </p:nvSpPr>
+        <p:spPr>
+          <a:xfrm>
+            <a:off x="8366760" y="1965960"/>
+            <a:ext cx="3200400" cy="4023360"/>
+          </a:xfrm>
+          <a:prstGeom prst="rect">
+            <a:avLst/>
+          </a:prstGeom>
+          <a:noFill/>
+          <a:ln/>
+        </p:spPr>
+        <p:txBody>
           <a:bodyPr wrap="square" lIns="0" tIns="0" rIns="0" bIns="0" rtlCol="0" anchor="t"/>
           <a:lstStyle/>
-          <a:p>
-            <a:pPr indent="0" marL="0">
-              <a:spcAft>
-                <a:spcPts val="600"/>
-              </a:spcAft>
-              <a:buNone/>
-            </a:pPr>
-            <a:r>
-              <a:rPr lang="en-US" sz="2200" b="1" dirty="0">
-                <a:solidFill>
-                  <a:srgbClr val="0072B2"/>
-                </a:solidFill>
-                <a:latin typeface="Calibri" pitchFamily="34" charset="0"/>
-                <a:ea typeface="Calibri" pitchFamily="34" charset="-122"/>
-                <a:cs typeface="Calibri" pitchFamily="34" charset="-120"/>
-              </a:rPr>
-              <a:t>Preguntas para SIMA</a:t>
-            </a:r>
-            <a:endParaRPr lang="en-US" sz="2200" dirty="0"/>
-          </a:p>
           <a:p>
             <a:pPr marL="228600" indent="-228600">
               <a:spcAft>
@@ -3484,9 +3514,9 @@
                 <a:ea typeface="Calibri" pitchFamily="34" charset="-122"/>
                 <a:cs typeface="Calibri" pitchFamily="34" charset="-120"/>
               </a:rPr>
-              <a:t>Fechas de cambio de sensores; ¿reubicaciones en 2021?</a:t>
-            </a:r>
-            <a:endParaRPr lang="en-US" sz="2200" dirty="0"/>
+              <a:t>La meteorología ayuda sobre todo en mar–may: base para una alerta con pronóstico</a:t>
+            </a:r>
+            <a:endParaRPr lang="en-US" sz="2000" dirty="0"/>
           </a:p>
           <a:p>
             <a:pPr marL="228600" indent="-228600">
@@ -3505,9 +3535,9 @@
                 <a:ea typeface="Calibri" pitchFamily="34" charset="-122"/>
                 <a:cs typeface="Calibri" pitchFamily="34" charset="-120"/>
               </a:rPr>
-              <a:t>¿Hora local? ¿Unidad de la lluvia?</a:t>
-            </a:r>
-            <a:endParaRPr lang="en-US" sz="2200" dirty="0"/>
+              <a:t>2 reglas de control de calidad que detectaron sensores con fallas</a:t>
+            </a:r>
+            <a:endParaRPr lang="en-US" sz="2000" dirty="0"/>
           </a:p>
           <a:p>
             <a:pPr marL="228600" indent="-228600">
@@ -3526,36 +3556,15 @@
                 <a:ea typeface="Calibri" pitchFamily="34" charset="-122"/>
                 <a:cs typeface="Calibri" pitchFamily="34" charset="-120"/>
               </a:rPr>
-              <a:t>¿Qué fuentes explican Juárez (SE2) y Santa Catarina (SO)?</a:t>
-            </a:r>
-            <a:endParaRPr lang="en-US" sz="2200" dirty="0"/>
-          </a:p>
-          <a:p>
-            <a:pPr marL="228600" indent="-228600">
-              <a:spcAft>
-                <a:spcPts val="800"/>
-              </a:spcAft>
-              <a:buSzPct val="100000"/>
-              <a:buChar char="•"/>
-            </a:pPr>
-            <a:r>
-              <a:rPr lang="en-US" sz="2000" dirty="0">
-                <a:solidFill>
-                  <a:srgbClr val="1F2933"/>
-                </a:solidFill>
-                <a:latin typeface="Calibri" pitchFamily="34" charset="0"/>
-                <a:ea typeface="Calibri" pitchFamily="34" charset="-122"/>
-                <a:cs typeface="Calibri" pitchFamily="34" charset="-120"/>
-              </a:rPr>
-              <a:t>¿Les serviría una alerta con pronóstico?</a:t>
-            </a:r>
-            <a:endParaRPr lang="en-US" sz="2200" dirty="0"/>
-          </a:p>
-        </p:txBody>
-      </p:sp>
-      <p:sp>
-        <p:nvSpPr>
-          <p:cNvPr id="11" name="enlace_repositorio"/>
+              <a:t>Base limpia y código abiertos, reproducibles</a:t>
+            </a:r>
+            <a:endParaRPr lang="en-US" sz="2000" dirty="0"/>
+          </a:p>
+        </p:txBody>
+      </p:sp>
+      <p:sp>
+        <p:nvSpPr>
+          <p:cNvPr id="13" name="enlace_repositorio"/>
           <p:cNvSpPr txBox="1"/>
           <p:nvPr/>
         </p:nvSpPr>

</xml_diff>